<commit_message>
Replace presentation files with corrected OpenMP slide
</commit_message>
<xml_diff>
--- a/presentations/llm-resource-allocation.pptx
+++ b/presentations/llm-resource-allocation.pptx
@@ -610,7 +610,7 @@
           <a:p>
             <a:r>
               <a:rPr lang="en-US" dirty="0"/>
-              <a:t/>
+              <a:t>Source at commit 80a9625: benchmarks/openmp_diagnostics_2026-10-14/analysis/extension.json, settings key "8_cores_close_dynamic_1_False_None", field speedup_vs_same_setting_one_thread.{ratio_of_medians, ci95_low, ci95_high} = 4.0223 [3.7636, 4.4243], valid_rounds=30; one-thread control key "1_cores_close_dynamic_1_False_None" (median 1.008776 s); eight-thread median 0.250794 s. Efficiency is the displayed speedup divided by eight. The chart is redrawn from the same file: keys "T_cores_close_S_1_False_None", with T the thread count from 1 to 16 and S one of static, dynamic or guided, 10,000 paired-round percentile resamples, seed 20261014; it shows the same series as the repository's plots/speedup.png. The core timer includes team creation and barriers and excludes parsing, output and warmup. This confirms a local throughput gain for the stated batch; the settings search is exploratory and a selected minimum is not an optimum. Physical P/E-core, cache, SMT and throttling causes remain unresolved in WSL (next slide). The older 18-round campaign (4.20x core, 2.27x invocation) keeps its own scope and is not combined with these thirty-round figures (Appendix A7). Native scheduling code: cpp/src/campaign.cpp.</a:t>
             </a:r>
             <a:endParaRPr lang="en-US" dirty="0"/>
           </a:p>
@@ -3256,7 +3256,7 @@
     <p:bg>
       <p:bgPr>
         <a:solidFill>
-          <a:srgbClr val="FFFFFF"/>
+          <a:srgbClr val="F6F4EE"/>
         </a:solidFill>
       </p:bgPr>
     </p:bg>
@@ -3274,6 +3274,640 @@
           <a:chExt cx="0" cy="0"/>
         </a:xfrm>
       </p:grpSpPr>
+      <p:sp>
+        <p:nvSpPr>
+          <p:cNvPr id="2" name="Text 0"/>
+          <p:cNvSpPr/>
+          <p:nvPr/>
+        </p:nvSpPr>
+        <p:spPr>
+          <a:xfrm>
+            <a:off x="812800" y="812800"/>
+            <a:ext cx="10883392" cy="238720"/>
+          </a:xfrm>
+          <a:prstGeom prst="rect">
+            <a:avLst/>
+          </a:prstGeom>
+          <a:noFill/>
+          <a:ln/>
+        </p:spPr>
+        <p:txBody>
+          <a:bodyPr wrap="square" lIns="0" tIns="0" rIns="0" bIns="0" rtlCol="0" anchor="t">
+            <a:normAutofit/>
+          </a:bodyPr>
+          <a:lstStyle/>
+          <a:p>
+            <a:pPr algn="l" indent="0" marL="0">
+              <a:lnSpc>
+                <a:spcPts val="1680"/>
+              </a:lnSpc>
+              <a:buNone/>
+            </a:pPr>
+            <a:r>
+              <a:rPr lang="en-US" sz="1200" b="1" spc="150" kern="0" dirty="0">
+                <a:solidFill>
+                  <a:srgbClr val="B8481A"/>
+                </a:solidFill>
+                <a:latin typeface="IBM Plex Sans" pitchFamily="34" charset="0"/>
+                <a:ea typeface="IBM Plex Sans" pitchFamily="34" charset="-122"/>
+                <a:cs typeface="IBM Plex Sans" pitchFamily="34" charset="-120"/>
+              </a:rPr>
+              <a:t>08 · OPENMP</a:t>
+            </a:r>
+            <a:endParaRPr lang="en-US" sz="1200" dirty="0"/>
+          </a:p>
+        </p:txBody>
+      </p:sp>
+      <p:sp>
+        <p:nvSpPr>
+          <p:cNvPr id="3" name="Text 1"/>
+          <p:cNvSpPr/>
+          <p:nvPr>
+            <p:ph type="title"/>
+          </p:nvPr>
+        </p:nvSpPr>
+        <p:spPr>
+          <a:xfrm>
+            <a:off x="812800" y="1102320"/>
+            <a:ext cx="10883392" cy="444500"/>
+          </a:xfrm>
+          <a:prstGeom prst="rect">
+            <a:avLst/>
+          </a:prstGeom>
+          <a:noFill/>
+          <a:ln/>
+        </p:spPr>
+        <p:txBody>
+          <a:bodyPr wrap="square" lIns="0" tIns="0" rIns="0" bIns="0" rtlCol="0" anchor="t">
+            <a:normAutofit/>
+          </a:bodyPr>
+          <a:lstStyle/>
+          <a:p>
+            <a:pPr algn="l" indent="0" marL="0">
+              <a:lnSpc>
+                <a:spcPts val="3300"/>
+              </a:lnSpc>
+              <a:buNone/>
+            </a:pPr>
+            <a:r>
+              <a:rPr lang="en-US" sz="3000" b="1" i="0" dirty="0">
+                <a:solidFill>
+                  <a:srgbClr val="14213D"/>
+                </a:solidFill>
+                <a:latin typeface="Source Serif 4" pitchFamily="18" charset="0"/>
+                <a:ea typeface="Source Serif 4" pitchFamily="18" charset="-122"/>
+                <a:cs typeface="Source Serif 4" pitchFamily="18" charset="-120"/>
+              </a:rPr>
+              <a:t>OpenMP runs independent cases concurrently</a:t>
+            </a:r>
+            <a:endParaRPr lang="en-US" sz="3000" dirty="0"/>
+          </a:p>
+        </p:txBody>
+      </p:sp>
+      <p:sp>
+        <p:nvSpPr>
+          <p:cNvPr id="4" name="Shape 2"/>
+          <p:cNvSpPr/>
+          <p:nvPr/>
+        </p:nvSpPr>
+        <p:spPr>
+          <a:xfrm>
+            <a:off x="812800" y="1750020"/>
+            <a:ext cx="6604000" cy="3365500"/>
+          </a:xfrm>
+          <a:prstGeom prst="roundRect">
+            <a:avLst>
+              <a:gd name="adj" fmla="val 3019"/>
+            </a:avLst>
+          </a:prstGeom>
+          <a:solidFill>
+            <a:srgbClr val="FFFFFF"/>
+          </a:solidFill>
+          <a:ln/>
+        </p:spPr>
+      </p:sp>
+      <p:pic>
+        <p:nvPicPr>
+          <p:cNvPr id="5" name="Image 0" descr="Core speedup against thread count for static, dynamic and guided schedules on a fixed 32-case batch, each against its own one-thread control, with 95% intervals; dynamic reaches 4.02 at 8 threads">    </p:cNvPr>
+          <p:cNvPicPr>
+            <a:picLocks noChangeAspect="1"/>
+          </p:cNvPicPr>
+          <p:nvPr/>
+        </p:nvPicPr>
+        <p:blipFill>
+          <a:blip r:embed="rId1"/>
+          <a:srcRect l="-41" r="-41" t="0" b="0"/>
+          <a:stretch/>
+        </p:blipFill>
+        <p:spPr>
+          <a:xfrm>
+            <a:off x="819150" y="1756370"/>
+            <a:ext cx="6591300" cy="3352800"/>
+          </a:xfrm>
+          <a:prstGeom prst="roundRect">
+            <a:avLst>
+              <a:gd name="adj" fmla="val 2841"/>
+            </a:avLst>
+          </a:prstGeom>
+        </p:spPr>
+      </p:pic>
+      <p:sp>
+        <p:nvSpPr>
+          <p:cNvPr id="6" name="Shape 3"/>
+          <p:cNvSpPr/>
+          <p:nvPr/>
+        </p:nvSpPr>
+        <p:spPr>
+          <a:xfrm>
+            <a:off x="815975" y="1753195"/>
+            <a:ext cx="6597650" cy="3359150"/>
+          </a:xfrm>
+          <a:prstGeom prst="roundRect">
+            <a:avLst>
+              <a:gd name="adj" fmla="val 2930"/>
+            </a:avLst>
+          </a:prstGeom>
+          <a:noFill/>
+          <a:ln w="6350">
+            <a:solidFill>
+              <a:srgbClr val="D9D5C8"/>
+            </a:solidFill>
+            <a:prstDash val="solid"/>
+          </a:ln>
+        </p:spPr>
+      </p:sp>
+      <p:sp>
+        <p:nvSpPr>
+          <p:cNvPr id="7" name="Text 4"/>
+          <p:cNvSpPr/>
+          <p:nvPr/>
+        </p:nvSpPr>
+        <p:spPr>
+          <a:xfrm>
+            <a:off x="812800" y="5217120"/>
+            <a:ext cx="6802120" cy="452041"/>
+          </a:xfrm>
+          <a:prstGeom prst="rect">
+            <a:avLst/>
+          </a:prstGeom>
+          <a:noFill/>
+          <a:ln/>
+        </p:spPr>
+        <p:txBody>
+          <a:bodyPr wrap="square" lIns="0" tIns="0" rIns="0" bIns="0" rtlCol="0" anchor="t">
+            <a:normAutofit/>
+          </a:bodyPr>
+          <a:lstStyle/>
+          <a:p>
+            <a:pPr algn="l" indent="0" marL="0">
+              <a:lnSpc>
+                <a:spcPts val="1680"/>
+              </a:lnSpc>
+              <a:buNone/>
+            </a:pPr>
+            <a:r>
+              <a:rPr lang="en-US" sz="1200" dirty="0">
+                <a:solidFill>
+                  <a:srgbClr val="4A5568"/>
+                </a:solidFill>
+                <a:latin typeface="IBM Plex Sans" pitchFamily="34" charset="0"/>
+                <a:ea typeface="IBM Plex Sans" pitchFamily="34" charset="-122"/>
+                <a:cs typeface="IBM Plex Sans" pitchFamily="34" charset="-120"/>
+              </a:rPr>
+              <a:t>Fixed mixed batch of 32 GH/AGH cases · cores/close · chunk 1 · unsorted · default allocator · 30 paired core rounds.</a:t>
+            </a:r>
+            <a:endParaRPr lang="en-US" sz="1200" dirty="0"/>
+          </a:p>
+        </p:txBody>
+      </p:sp>
+      <p:sp>
+        <p:nvSpPr>
+          <p:cNvPr id="8" name="Shape 5"/>
+          <p:cNvSpPr/>
+          <p:nvPr/>
+        </p:nvSpPr>
+        <p:spPr>
+          <a:xfrm>
+            <a:off x="7670800" y="1750020"/>
+            <a:ext cx="3708400" cy="1183531"/>
+          </a:xfrm>
+          <a:prstGeom prst="roundRect">
+            <a:avLst>
+              <a:gd name="adj" fmla="val 8584"/>
+            </a:avLst>
+          </a:prstGeom>
+          <a:solidFill>
+            <a:srgbClr val="14213D"/>
+          </a:solidFill>
+          <a:ln/>
+        </p:spPr>
+      </p:sp>
+      <p:sp>
+        <p:nvSpPr>
+          <p:cNvPr id="9" name="Text 6"/>
+          <p:cNvSpPr/>
+          <p:nvPr/>
+        </p:nvSpPr>
+        <p:spPr>
+          <a:xfrm>
+            <a:off x="7848600" y="1902420"/>
+            <a:ext cx="3453384" cy="452090"/>
+          </a:xfrm>
+          <a:prstGeom prst="rect">
+            <a:avLst/>
+          </a:prstGeom>
+          <a:noFill/>
+          <a:ln/>
+        </p:spPr>
+        <p:txBody>
+          <a:bodyPr wrap="square" lIns="0" tIns="0" rIns="0" bIns="0" rtlCol="0" anchor="t">
+            <a:normAutofit/>
+          </a:bodyPr>
+          <a:lstStyle/>
+          <a:p>
+            <a:pPr algn="l" indent="0" marL="0">
+              <a:lnSpc>
+                <a:spcPts val="3360"/>
+              </a:lnSpc>
+              <a:buNone/>
+            </a:pPr>
+            <a:r>
+              <a:rPr lang="en-US" sz="3200" b="1" dirty="0">
+                <a:solidFill>
+                  <a:srgbClr val="F6F4EE"/>
+                </a:solidFill>
+                <a:latin typeface="Source Serif 4" pitchFamily="18" charset="0"/>
+                <a:ea typeface="Source Serif 4" pitchFamily="18" charset="-122"/>
+                <a:cs typeface="Source Serif 4" pitchFamily="18" charset="-120"/>
+              </a:rPr>
+              <a:t>4.02×</a:t>
+            </a:r>
+            <a:endParaRPr lang="en-US" sz="3200" dirty="0"/>
+          </a:p>
+        </p:txBody>
+      </p:sp>
+      <p:sp>
+        <p:nvSpPr>
+          <p:cNvPr id="10" name="Text 7"/>
+          <p:cNvSpPr/>
+          <p:nvPr/>
+        </p:nvSpPr>
+        <p:spPr>
+          <a:xfrm>
+            <a:off x="7848600" y="2354511"/>
+            <a:ext cx="3453384" cy="452041"/>
+          </a:xfrm>
+          <a:prstGeom prst="rect">
+            <a:avLst/>
+          </a:prstGeom>
+          <a:noFill/>
+          <a:ln/>
+        </p:spPr>
+        <p:txBody>
+          <a:bodyPr wrap="square" lIns="0" tIns="0" rIns="0" bIns="0" rtlCol="0" anchor="t">
+            <a:normAutofit/>
+          </a:bodyPr>
+          <a:lstStyle/>
+          <a:p>
+            <a:pPr algn="l" indent="0" marL="0">
+              <a:lnSpc>
+                <a:spcPts val="1680"/>
+              </a:lnSpc>
+              <a:buNone/>
+            </a:pPr>
+            <a:r>
+              <a:rPr lang="en-US" sz="1200" dirty="0">
+                <a:solidFill>
+                  <a:srgbClr val="C9D3E3"/>
+                </a:solidFill>
+                <a:latin typeface="IBM Plex Sans" pitchFamily="34" charset="0"/>
+                <a:ea typeface="IBM Plex Sans" pitchFamily="34" charset="-122"/>
+                <a:cs typeface="IBM Plex Sans" pitchFamily="34" charset="-120"/>
+              </a:rPr>
+              <a:t>8 threads, dynamic, vs its own one-thread control · 95% CI [3.76, 4.42]</a:t>
+            </a:r>
+            <a:endParaRPr lang="en-US" sz="1200" dirty="0"/>
+          </a:p>
+        </p:txBody>
+      </p:sp>
+      <p:sp>
+        <p:nvSpPr>
+          <p:cNvPr id="11" name="Shape 8"/>
+          <p:cNvSpPr/>
+          <p:nvPr/>
+        </p:nvSpPr>
+        <p:spPr>
+          <a:xfrm>
+            <a:off x="7673975" y="3038326"/>
+            <a:ext cx="3702050" cy="976561"/>
+          </a:xfrm>
+          <a:prstGeom prst="roundRect">
+            <a:avLst>
+              <a:gd name="adj" fmla="val 10079"/>
+            </a:avLst>
+          </a:prstGeom>
+          <a:solidFill>
+            <a:srgbClr val="FDFCF9"/>
+          </a:solidFill>
+          <a:ln w="6350">
+            <a:solidFill>
+              <a:srgbClr val="D9D5C8"/>
+            </a:solidFill>
+            <a:prstDash val="solid"/>
+          </a:ln>
+        </p:spPr>
+      </p:sp>
+      <p:sp>
+        <p:nvSpPr>
+          <p:cNvPr id="12" name="Text 9"/>
+          <p:cNvSpPr/>
+          <p:nvPr/>
+        </p:nvSpPr>
+        <p:spPr>
+          <a:xfrm>
+            <a:off x="7854950" y="3193901"/>
+            <a:ext cx="3440303" cy="452090"/>
+          </a:xfrm>
+          <a:prstGeom prst="rect">
+            <a:avLst/>
+          </a:prstGeom>
+          <a:noFill/>
+          <a:ln/>
+        </p:spPr>
+        <p:txBody>
+          <a:bodyPr wrap="square" lIns="0" tIns="0" rIns="0" bIns="0" rtlCol="0" anchor="t">
+            <a:normAutofit/>
+          </a:bodyPr>
+          <a:lstStyle/>
+          <a:p>
+            <a:pPr algn="l" indent="0" marL="0">
+              <a:lnSpc>
+                <a:spcPts val="3360"/>
+              </a:lnSpc>
+              <a:buNone/>
+            </a:pPr>
+            <a:r>
+              <a:rPr lang="en-US" sz="3200" b="1" dirty="0">
+                <a:solidFill>
+                  <a:srgbClr val="14213D"/>
+                </a:solidFill>
+                <a:latin typeface="Source Serif 4" pitchFamily="18" charset="0"/>
+                <a:ea typeface="Source Serif 4" pitchFamily="18" charset="-122"/>
+                <a:cs typeface="Source Serif 4" pitchFamily="18" charset="-120"/>
+              </a:rPr>
+              <a:t>50.28%</a:t>
+            </a:r>
+            <a:endParaRPr lang="en-US" sz="3200" dirty="0"/>
+          </a:p>
+        </p:txBody>
+      </p:sp>
+      <p:sp>
+        <p:nvSpPr>
+          <p:cNvPr id="13" name="Text 10"/>
+          <p:cNvSpPr/>
+          <p:nvPr/>
+        </p:nvSpPr>
+        <p:spPr>
+          <a:xfrm>
+            <a:off x="7854950" y="3645991"/>
+            <a:ext cx="3440303" cy="238720"/>
+          </a:xfrm>
+          <a:prstGeom prst="rect">
+            <a:avLst/>
+          </a:prstGeom>
+          <a:noFill/>
+          <a:ln/>
+        </p:spPr>
+        <p:txBody>
+          <a:bodyPr wrap="square" lIns="0" tIns="0" rIns="0" bIns="0" rtlCol="0" anchor="t">
+            <a:normAutofit/>
+          </a:bodyPr>
+          <a:lstStyle/>
+          <a:p>
+            <a:pPr algn="l" indent="0" marL="0">
+              <a:lnSpc>
+                <a:spcPts val="1680"/>
+              </a:lnSpc>
+              <a:buNone/>
+            </a:pPr>
+            <a:r>
+              <a:rPr lang="en-US" sz="1200" dirty="0">
+                <a:solidFill>
+                  <a:srgbClr val="4A5568"/>
+                </a:solidFill>
+                <a:latin typeface="IBM Plex Sans" pitchFamily="34" charset="0"/>
+                <a:ea typeface="IBM Plex Sans" pitchFamily="34" charset="-122"/>
+                <a:cs typeface="IBM Plex Sans" pitchFamily="34" charset="-120"/>
+              </a:rPr>
+              <a:t>efficiency = speedup / 8</a:t>
+            </a:r>
+            <a:endParaRPr lang="en-US" sz="1200" dirty="0"/>
+          </a:p>
+        </p:txBody>
+      </p:sp>
+      <p:sp>
+        <p:nvSpPr>
+          <p:cNvPr id="14" name="Shape 11"/>
+          <p:cNvSpPr/>
+          <p:nvPr/>
+        </p:nvSpPr>
+        <p:spPr>
+          <a:xfrm>
+            <a:off x="7673975" y="4122837"/>
+            <a:ext cx="3702050" cy="1517749"/>
+          </a:xfrm>
+          <a:prstGeom prst="roundRect">
+            <a:avLst>
+              <a:gd name="adj" fmla="val 6485"/>
+            </a:avLst>
+          </a:prstGeom>
+          <a:solidFill>
+            <a:srgbClr val="FDFCF9"/>
+          </a:solidFill>
+          <a:ln w="6350">
+            <a:solidFill>
+              <a:srgbClr val="D9D5C8"/>
+            </a:solidFill>
+            <a:prstDash val="solid"/>
+          </a:ln>
+        </p:spPr>
+      </p:sp>
+      <p:sp>
+        <p:nvSpPr>
+          <p:cNvPr id="15" name="Text 12"/>
+          <p:cNvSpPr/>
+          <p:nvPr/>
+        </p:nvSpPr>
+        <p:spPr>
+          <a:xfrm>
+            <a:off x="7854950" y="4278412"/>
+            <a:ext cx="3440303" cy="238720"/>
+          </a:xfrm>
+          <a:prstGeom prst="rect">
+            <a:avLst/>
+          </a:prstGeom>
+          <a:noFill/>
+          <a:ln/>
+        </p:spPr>
+        <p:txBody>
+          <a:bodyPr wrap="square" lIns="0" tIns="0" rIns="0" bIns="0" rtlCol="0" anchor="t">
+            <a:normAutofit/>
+          </a:bodyPr>
+          <a:lstStyle/>
+          <a:p>
+            <a:pPr algn="l" indent="0" marL="0">
+              <a:lnSpc>
+                <a:spcPts val="1680"/>
+              </a:lnSpc>
+              <a:buNone/>
+            </a:pPr>
+            <a:r>
+              <a:rPr lang="en-US" sz="1200" b="1" spc="150" kern="0" dirty="0">
+                <a:solidFill>
+                  <a:srgbClr val="2561A6"/>
+                </a:solidFill>
+                <a:latin typeface="IBM Plex Sans" pitchFamily="34" charset="0"/>
+                <a:ea typeface="IBM Plex Sans" pitchFamily="34" charset="-122"/>
+                <a:cs typeface="IBM Plex Sans" pitchFamily="34" charset="-120"/>
+              </a:rPr>
+              <a:t>WORK UNIT</a:t>
+            </a:r>
+            <a:endParaRPr lang="en-US" sz="1200" dirty="0"/>
+          </a:p>
+        </p:txBody>
+      </p:sp>
+      <p:sp>
+        <p:nvSpPr>
+          <p:cNvPr id="16" name="Text 13"/>
+          <p:cNvSpPr/>
+          <p:nvPr/>
+        </p:nvSpPr>
+        <p:spPr>
+          <a:xfrm>
+            <a:off x="7854950" y="4542532"/>
+            <a:ext cx="3440303" cy="878681"/>
+          </a:xfrm>
+          <a:prstGeom prst="rect">
+            <a:avLst/>
+          </a:prstGeom>
+          <a:noFill/>
+          <a:ln/>
+        </p:spPr>
+        <p:txBody>
+          <a:bodyPr wrap="square" lIns="0" tIns="0" rIns="0" bIns="0" rtlCol="0" anchor="t">
+            <a:normAutofit/>
+          </a:bodyPr>
+          <a:lstStyle/>
+          <a:p>
+            <a:pPr algn="l" indent="0" marL="0">
+              <a:lnSpc>
+                <a:spcPts val="1680"/>
+              </a:lnSpc>
+              <a:buNone/>
+            </a:pPr>
+            <a:r>
+              <a:rPr lang="en-US" sz="1200" dirty="0">
+                <a:solidFill>
+                  <a:srgbClr val="4A5568"/>
+                </a:solidFill>
+                <a:latin typeface="IBM Plex Sans" pitchFamily="34" charset="0"/>
+                <a:ea typeface="IBM Plex Sans" pitchFamily="34" charset="-122"/>
+                <a:cs typeface="IBM Plex Sans" pitchFamily="34" charset="-120"/>
+              </a:rPr>
+              <a:t>One independent allocation case per task. Each GH/AGH solve stays serial; this is batch throughput, not a faster single solve or GPU inference.</a:t>
+            </a:r>
+            <a:endParaRPr lang="en-US" sz="1200" dirty="0"/>
+          </a:p>
+        </p:txBody>
+      </p:sp>
+      <p:sp>
+        <p:nvSpPr>
+          <p:cNvPr id="17" name="Text 14"/>
+          <p:cNvSpPr/>
+          <p:nvPr/>
+        </p:nvSpPr>
+        <p:spPr>
+          <a:xfrm>
+            <a:off x="812800" y="6238280"/>
+            <a:ext cx="9810750" cy="238720"/>
+          </a:xfrm>
+          <a:prstGeom prst="rect">
+            <a:avLst/>
+          </a:prstGeom>
+          <a:noFill/>
+          <a:ln/>
+        </p:spPr>
+        <p:txBody>
+          <a:bodyPr wrap="square" lIns="0" tIns="0" rIns="0" bIns="0" rtlCol="0" anchor="t">
+            <a:normAutofit/>
+          </a:bodyPr>
+          <a:lstStyle/>
+          <a:p>
+            <a:pPr algn="l" indent="0" marL="0">
+              <a:lnSpc>
+                <a:spcPts val="1680"/>
+              </a:lnSpc>
+              <a:buNone/>
+            </a:pPr>
+            <a:r>
+              <a:rPr lang="en-US" sz="1200" dirty="0">
+                <a:solidFill>
+                  <a:srgbClr val="5B6472"/>
+                </a:solidFill>
+                <a:latin typeface="IBM Plex Sans" pitchFamily="34" charset="0"/>
+                <a:ea typeface="IBM Plex Sans" pitchFamily="34" charset="-122"/>
+                <a:cs typeface="IBM Plex Sans" pitchFamily="34" charset="-120"/>
+              </a:rPr>
+              <a:t>Source: WP2 OpenMP analysis · i7-13620H, WSL · commit 80a9625.</a:t>
+            </a:r>
+            <a:endParaRPr lang="en-US" sz="1200" dirty="0"/>
+          </a:p>
+        </p:txBody>
+      </p:sp>
+      <p:sp>
+        <p:nvSpPr>
+          <p:cNvPr id="18" name="Text 15"/>
+          <p:cNvSpPr/>
+          <p:nvPr/>
+        </p:nvSpPr>
+        <p:spPr>
+          <a:xfrm>
+            <a:off x="10312400" y="6238280"/>
+            <a:ext cx="1066800" cy="238720"/>
+          </a:xfrm>
+          <a:prstGeom prst="rect">
+            <a:avLst/>
+          </a:prstGeom>
+          <a:noFill/>
+          <a:ln/>
+        </p:spPr>
+        <p:txBody>
+          <a:bodyPr wrap="square" lIns="0" tIns="0" rIns="0" bIns="0" rtlCol="0" anchor="t">
+            <a:normAutofit/>
+          </a:bodyPr>
+          <a:lstStyle/>
+          <a:p>
+            <a:pPr algn="r" indent="0" marL="0">
+              <a:lnSpc>
+                <a:spcPts val="1680"/>
+              </a:lnSpc>
+              <a:buNone/>
+            </a:pPr>
+            <a:r>
+              <a:rPr lang="en-US" sz="1200" dirty="0">
+                <a:solidFill>
+                  <a:srgbClr val="5B6472"/>
+                </a:solidFill>
+                <a:latin typeface="IBM Plex Sans" pitchFamily="34" charset="0"/>
+                <a:ea typeface="IBM Plex Sans" pitchFamily="34" charset="-122"/>
+                <a:cs typeface="IBM Plex Sans" pitchFamily="34" charset="-120"/>
+              </a:rPr>
+              <a:t>10 / 21</a:t>
+            </a:r>
+            <a:endParaRPr lang="en-US" sz="1200" dirty="0"/>
+          </a:p>
+        </p:txBody>
+      </p:sp>
     </p:spTree>
   </p:cSld>
   <p:clrMapOvr>

</xml_diff>

<commit_message>
Update presentation layout on slides 17 and 18
</commit_message>
<xml_diff>
--- a/presentations/llm-resource-allocation.pptx
+++ b/presentations/llm-resource-allocation.pptx
@@ -11018,7 +11018,7 @@
         <p:spPr>
           <a:xfrm>
             <a:off x="812800" y="812800"/>
-            <a:ext cx="10883392" cy="212973"/>
+            <a:ext cx="10883392" cy="238720"/>
           </a:xfrm>
           <a:prstGeom prst="rect">
             <a:avLst/>
@@ -11034,12 +11034,12 @@
           <a:p>
             <a:pPr algn="l" indent="0" marL="0">
               <a:lnSpc>
-                <a:spcPts val="1523"/>
+                <a:spcPts val="1680"/>
               </a:lnSpc>
               <a:buNone/>
             </a:pPr>
             <a:r>
-              <a:rPr lang="en-US" sz="1088" b="1" spc="150" kern="0" dirty="0">
+              <a:rPr lang="en-US" sz="1200" b="1" spc="150" kern="0" dirty="0">
                 <a:solidFill>
                   <a:srgbClr val="B8481A"/>
                 </a:solidFill>
@@ -11049,7 +11049,7 @@
               </a:rPr>
               <a:t>APPENDIX A4 · STAGE 2, ORIGINAL CAMPAIGN (OCT 13)</a:t>
             </a:r>
-            <a:endParaRPr lang="en-US" sz="1088" dirty="0"/>
+            <a:endParaRPr lang="en-US" sz="1200" dirty="0"/>
           </a:p>
         </p:txBody>
       </p:sp>
@@ -11063,8 +11063,8 @@
         </p:nvSpPr>
         <p:spPr>
           <a:xfrm>
-            <a:off x="812800" y="1076573"/>
-            <a:ext cx="10883392" cy="393849"/>
+            <a:off x="812800" y="1102320"/>
+            <a:ext cx="10883392" cy="444500"/>
           </a:xfrm>
           <a:prstGeom prst="rect">
             <a:avLst/>
@@ -11080,12 +11080,12 @@
           <a:p>
             <a:pPr algn="l" indent="0" marL="0">
               <a:lnSpc>
-                <a:spcPts val="2918"/>
+                <a:spcPts val="3300"/>
               </a:lnSpc>
               <a:buNone/>
             </a:pPr>
             <a:r>
-              <a:rPr lang="en-US" sz="2653" b="1" i="0" dirty="0">
+              <a:rPr lang="en-US" sz="3000" b="1" i="0" dirty="0">
                 <a:solidFill>
                   <a:srgbClr val="14213D"/>
                 </a:solidFill>
@@ -11095,7 +11095,7 @@
               </a:rPr>
               <a:t>Standard policy: 1,850 operational attempts</a:t>
             </a:r>
-            <a:endParaRPr lang="en-US" sz="2653" dirty="0"/>
+            <a:endParaRPr lang="en-US" sz="3000" dirty="0"/>
           </a:p>
         </p:txBody>
       </p:sp>
@@ -11107,12 +11107,12 @@
         </p:nvSpPr>
         <p:spPr>
           <a:xfrm>
-            <a:off x="815975" y="1676797"/>
-            <a:ext cx="6724650" cy="4162028"/>
+            <a:off x="815975" y="1753195"/>
+            <a:ext cx="6724650" cy="3802261"/>
           </a:xfrm>
           <a:prstGeom prst="roundRect">
             <a:avLst>
-              <a:gd name="adj" fmla="val 2365"/>
+              <a:gd name="adj" fmla="val 2589"/>
             </a:avLst>
           </a:prstGeom>
           <a:solidFill>
@@ -11134,8 +11134,8 @@
         </p:nvSpPr>
         <p:spPr>
           <a:xfrm>
-            <a:off x="1022350" y="1883172"/>
-            <a:ext cx="6501257" cy="203250"/>
+            <a:off x="1022350" y="1959570"/>
+            <a:ext cx="6501257" cy="238720"/>
           </a:xfrm>
           <a:prstGeom prst="rect">
             <a:avLst/>
@@ -11151,12 +11151,12 @@
           <a:p>
             <a:pPr algn="l" indent="0" marL="0">
               <a:lnSpc>
-                <a:spcPts val="1423"/>
+                <a:spcPts val="1680"/>
               </a:lnSpc>
               <a:buNone/>
             </a:pPr>
             <a:r>
-              <a:rPr lang="en-US" sz="1016" b="1" spc="150" kern="0" dirty="0">
+              <a:rPr lang="en-US" sz="1200" b="1" spc="150" kern="0" dirty="0">
                 <a:solidFill>
                   <a:srgbClr val="2561A6"/>
                 </a:solidFill>
@@ -11166,7 +11166,7 @@
               </a:rPr>
               <a:t>OUTCOME OF EACH ATTEMPTED LP</a:t>
             </a:r>
-            <a:endParaRPr lang="en-US" sz="1016" dirty="0"/>
+            <a:endParaRPr lang="en-US" sz="1200" dirty="0"/>
           </a:p>
         </p:txBody>
       </p:sp>
@@ -11178,8 +11178,8 @@
         </p:nvSpPr>
         <p:spPr>
           <a:xfrm>
-            <a:off x="1022350" y="2298551"/>
-            <a:ext cx="2158365" cy="274290"/>
+            <a:off x="1022350" y="2442121"/>
+            <a:ext cx="2223770" cy="274290"/>
           </a:xfrm>
           <a:prstGeom prst="rect">
             <a:avLst/>
@@ -11222,8 +11222,8 @@
         </p:nvSpPr>
         <p:spPr>
           <a:xfrm>
-            <a:off x="3270250" y="2232521"/>
-            <a:ext cx="2463800" cy="381000"/>
+            <a:off x="3333750" y="2376091"/>
+            <a:ext cx="1968500" cy="381000"/>
           </a:xfrm>
           <a:prstGeom prst="rect">
             <a:avLst/>
@@ -11242,8 +11242,8 @@
         </p:nvSpPr>
         <p:spPr>
           <a:xfrm>
-            <a:off x="5886450" y="2298551"/>
-            <a:ext cx="384096" cy="274290"/>
+            <a:off x="5454650" y="2442121"/>
+            <a:ext cx="812800" cy="274290"/>
           </a:xfrm>
           <a:prstGeom prst="rect">
             <a:avLst/>
@@ -11286,8 +11286,8 @@
         </p:nvSpPr>
         <p:spPr>
           <a:xfrm>
-            <a:off x="1022350" y="3179266"/>
-            <a:ext cx="2158365" cy="274290"/>
+            <a:off x="1022350" y="3026321"/>
+            <a:ext cx="2223770" cy="274290"/>
           </a:xfrm>
           <a:prstGeom prst="rect">
             <a:avLst/>
@@ -11330,8 +11330,8 @@
         </p:nvSpPr>
         <p:spPr>
           <a:xfrm>
-            <a:off x="3270250" y="3113236"/>
-            <a:ext cx="3810000" cy="381000"/>
+            <a:off x="3333750" y="2960291"/>
+            <a:ext cx="3048000" cy="381000"/>
           </a:xfrm>
           <a:prstGeom prst="rect">
             <a:avLst/>
@@ -11350,8 +11350,8 @@
         </p:nvSpPr>
         <p:spPr>
           <a:xfrm>
-            <a:off x="7232650" y="2681536"/>
-            <a:ext cx="152400" cy="1269851"/>
+            <a:off x="6534150" y="3026321"/>
+            <a:ext cx="812800" cy="274290"/>
           </a:xfrm>
           <a:prstGeom prst="rect">
             <a:avLst/>
@@ -11394,8 +11394,8 @@
         </p:nvSpPr>
         <p:spPr>
           <a:xfrm>
-            <a:off x="1022350" y="4059982"/>
-            <a:ext cx="2158365" cy="274290"/>
+            <a:off x="1022350" y="3610521"/>
+            <a:ext cx="2223770" cy="274290"/>
           </a:xfrm>
           <a:prstGeom prst="rect">
             <a:avLst/>
@@ -11438,8 +11438,8 @@
         </p:nvSpPr>
         <p:spPr>
           <a:xfrm>
-            <a:off x="3270250" y="3993952"/>
-            <a:ext cx="774700" cy="381000"/>
+            <a:off x="3333750" y="3544491"/>
+            <a:ext cx="622300" cy="381000"/>
           </a:xfrm>
           <a:prstGeom prst="rect">
             <a:avLst/>
@@ -11458,8 +11458,8 @@
         </p:nvSpPr>
         <p:spPr>
           <a:xfrm>
-            <a:off x="4197350" y="4059982"/>
-            <a:ext cx="384096" cy="274290"/>
+            <a:off x="4108450" y="3610521"/>
+            <a:ext cx="812800" cy="274290"/>
           </a:xfrm>
           <a:prstGeom prst="rect">
             <a:avLst/>
@@ -11509,7 +11509,7 @@
         </p:blipFill>
         <p:spPr>
           <a:xfrm>
-            <a:off x="1022350" y="4546451"/>
+            <a:off x="1022350" y="4128691"/>
             <a:ext cx="6311900" cy="6350"/>
           </a:xfrm>
           <a:prstGeom prst="rect">
@@ -11525,8 +11525,8 @@
         </p:nvSpPr>
         <p:spPr>
           <a:xfrm>
-            <a:off x="1022350" y="4790331"/>
-            <a:ext cx="2158365" cy="274290"/>
+            <a:off x="1022350" y="4404271"/>
+            <a:ext cx="2223770" cy="274290"/>
           </a:xfrm>
           <a:prstGeom prst="rect">
             <a:avLst/>
@@ -11569,8 +11569,8 @@
         </p:nvSpPr>
         <p:spPr>
           <a:xfrm>
-            <a:off x="3276600" y="4730651"/>
-            <a:ext cx="558800" cy="368300"/>
+            <a:off x="3340100" y="4344591"/>
+            <a:ext cx="444500" cy="368300"/>
           </a:xfrm>
           <a:prstGeom prst="rect">
             <a:avLst/>
@@ -11592,8 +11592,8 @@
         </p:nvSpPr>
         <p:spPr>
           <a:xfrm>
-            <a:off x="3994150" y="4790331"/>
-            <a:ext cx="384096" cy="274290"/>
+            <a:off x="3943350" y="4404271"/>
+            <a:ext cx="812800" cy="274290"/>
           </a:xfrm>
           <a:prstGeom prst="rect">
             <a:avLst/>
@@ -11636,8 +11636,8 @@
         </p:nvSpPr>
         <p:spPr>
           <a:xfrm>
-            <a:off x="1022350" y="5276800"/>
-            <a:ext cx="6501257" cy="381050"/>
+            <a:off x="1022350" y="4922441"/>
+            <a:ext cx="6501257" cy="452041"/>
           </a:xfrm>
           <a:prstGeom prst="rect">
             <a:avLst/>
@@ -11653,12 +11653,12 @@
           <a:p>
             <a:pPr algn="l" indent="0" marL="0">
               <a:lnSpc>
-                <a:spcPts val="1412"/>
+                <a:spcPts val="1680"/>
               </a:lnSpc>
               <a:buNone/>
             </a:pPr>
             <a:r>
-              <a:rPr lang="en-US" sz="1009" dirty="0">
+              <a:rPr lang="en-US" sz="1200" dirty="0">
                 <a:solidFill>
                   <a:srgbClr val="4A5568"/>
                 </a:solidFill>
@@ -11668,7 +11668,7 @@
               </a:rPr>
               <a:t>A completed run is not an accepted decision. The 150 skipped scenarios follow three rejected Stage-1 sources and lie outside the 1,850 attempts.</a:t>
             </a:r>
-            <a:endParaRPr lang="en-US" sz="1009" dirty="0"/>
+            <a:endParaRPr lang="en-US" sz="1200" dirty="0"/>
           </a:p>
         </p:txBody>
       </p:sp>
@@ -11680,7 +11680,7 @@
         </p:nvSpPr>
         <p:spPr>
           <a:xfrm>
-            <a:off x="7797800" y="1673622"/>
+            <a:off x="7797800" y="1750020"/>
             <a:ext cx="3581400" cy="1183531"/>
           </a:xfrm>
           <a:prstGeom prst="roundRect">
@@ -11702,7 +11702,7 @@
         </p:nvSpPr>
         <p:spPr>
           <a:xfrm>
-            <a:off x="7975600" y="1826022"/>
+            <a:off x="7975600" y="1902420"/>
             <a:ext cx="3322574" cy="452090"/>
           </a:xfrm>
           <a:prstGeom prst="rect">
@@ -11746,7 +11746,7 @@
         </p:nvSpPr>
         <p:spPr>
           <a:xfrm>
-            <a:off x="7975600" y="2278112"/>
+            <a:off x="7975600" y="2354511"/>
             <a:ext cx="3322574" cy="452041"/>
           </a:xfrm>
           <a:prstGeom prst="rect">
@@ -11790,7 +11790,7 @@
         </p:nvSpPr>
         <p:spPr>
           <a:xfrm>
-            <a:off x="7800975" y="2961928"/>
+            <a:off x="7800975" y="3038326"/>
             <a:ext cx="3575050" cy="1189881"/>
           </a:xfrm>
           <a:prstGeom prst="roundRect">
@@ -11817,7 +11817,7 @@
         </p:nvSpPr>
         <p:spPr>
           <a:xfrm>
-            <a:off x="7981950" y="3117503"/>
+            <a:off x="7981950" y="3193901"/>
             <a:ext cx="3309493" cy="452090"/>
           </a:xfrm>
           <a:prstGeom prst="rect">
@@ -11861,7 +11861,7 @@
         </p:nvSpPr>
         <p:spPr>
           <a:xfrm>
-            <a:off x="7981950" y="3569593"/>
+            <a:off x="7981950" y="3645991"/>
             <a:ext cx="3309493" cy="452041"/>
           </a:xfrm>
           <a:prstGeom prst="rect">
@@ -11905,12 +11905,12 @@
         </p:nvSpPr>
         <p:spPr>
           <a:xfrm>
-            <a:off x="7800975" y="4259759"/>
-            <a:ext cx="3575050" cy="1579066"/>
+            <a:off x="7800975" y="4336157"/>
+            <a:ext cx="3575050" cy="1219299"/>
           </a:xfrm>
           <a:prstGeom prst="roundRect">
             <a:avLst>
-              <a:gd name="adj" fmla="val 6233"/>
+              <a:gd name="adj" fmla="val 8072"/>
             </a:avLst>
           </a:prstGeom>
           <a:solidFill>
@@ -11932,7 +11932,7 @@
         </p:nvSpPr>
         <p:spPr>
           <a:xfrm>
-            <a:off x="7981950" y="4415334"/>
+            <a:off x="7981950" y="4491732"/>
             <a:ext cx="3309493" cy="452090"/>
           </a:xfrm>
           <a:prstGeom prst="rect">
@@ -11976,7 +11976,7 @@
         </p:nvSpPr>
         <p:spPr>
           <a:xfrm>
-            <a:off x="7981950" y="4867424"/>
+            <a:off x="7981950" y="4943822"/>
             <a:ext cx="3309493" cy="452041"/>
           </a:xfrm>
           <a:prstGeom prst="rect">
@@ -12231,11 +12231,11 @@
         <p:spPr>
           <a:xfrm>
             <a:off x="815975" y="1753195"/>
-            <a:ext cx="6978650" cy="1906141"/>
+            <a:ext cx="6978650" cy="1438870"/>
           </a:xfrm>
           <a:prstGeom prst="roundRect">
             <a:avLst>
-              <a:gd name="adj" fmla="val 5164"/>
+              <a:gd name="adj" fmla="val 6840"/>
             </a:avLst>
           </a:prstGeom>
           <a:solidFill>
@@ -12346,7 +12346,7 @@
         <p:spPr>
           <a:xfrm>
             <a:off x="3460750" y="2299891"/>
-            <a:ext cx="2895600" cy="279400"/>
+            <a:ext cx="2413000" cy="279400"/>
           </a:xfrm>
           <a:prstGeom prst="rect">
             <a:avLst/>
@@ -12365,8 +12365,8 @@
         </p:nvSpPr>
         <p:spPr>
           <a:xfrm>
-            <a:off x="6508750" y="2315121"/>
-            <a:ext cx="384096" cy="274290"/>
+            <a:off x="6026150" y="2315121"/>
+            <a:ext cx="749300" cy="274290"/>
           </a:xfrm>
           <a:prstGeom prst="rect">
             <a:avLst/>
@@ -12409,7 +12409,7 @@
         </p:nvSpPr>
         <p:spPr>
           <a:xfrm>
-            <a:off x="1022350" y="2955181"/>
+            <a:off x="1022350" y="2721521"/>
             <a:ext cx="2354580" cy="274290"/>
           </a:xfrm>
           <a:prstGeom prst="rect">
@@ -12453,8 +12453,8 @@
         </p:nvSpPr>
         <p:spPr>
           <a:xfrm>
-            <a:off x="3460750" y="2939901"/>
-            <a:ext cx="3810000" cy="279400"/>
+            <a:off x="3460750" y="2706291"/>
+            <a:ext cx="3175000" cy="279400"/>
           </a:xfrm>
           <a:prstGeom prst="rect">
             <a:avLst/>
@@ -12473,8 +12473,8 @@
         </p:nvSpPr>
         <p:spPr>
           <a:xfrm>
-            <a:off x="7423150" y="2706291"/>
-            <a:ext cx="215900" cy="772071"/>
+            <a:off x="6788150" y="2721521"/>
+            <a:ext cx="749300" cy="274290"/>
           </a:xfrm>
           <a:prstGeom prst="rect">
             <a:avLst/>
@@ -12517,7 +12517,7 @@
         </p:nvSpPr>
         <p:spPr>
           <a:xfrm>
-            <a:off x="812800" y="3789511"/>
+            <a:off x="812800" y="3322241"/>
             <a:ext cx="6985000" cy="1017091"/>
           </a:xfrm>
           <a:prstGeom prst="rect">
@@ -12537,7 +12537,7 @@
         </p:nvSpPr>
         <p:spPr>
           <a:xfrm>
-            <a:off x="7794625" y="3789511"/>
+            <a:off x="7794625" y="3322241"/>
             <a:ext cx="0" cy="1017091"/>
           </a:xfrm>
           <a:prstGeom prst="line">
@@ -12560,7 +12560,7 @@
         </p:nvSpPr>
         <p:spPr>
           <a:xfrm>
-            <a:off x="812800" y="4803428"/>
+            <a:off x="812800" y="4336157"/>
             <a:ext cx="6985000" cy="0"/>
           </a:xfrm>
           <a:prstGeom prst="line">
@@ -12590,7 +12590,7 @@
           </p:nvPr>
         </p:nvGraphicFramePr>
         <p:xfrm>
-          <a:off x="825500" y="3802211"/>
+          <a:off x="825500" y="3334941"/>
           <a:ext cx="6965950" cy="998041"/>
         </p:xfrm>
         <a:graphic>
@@ -13241,7 +13241,7 @@
         </p:nvSpPr>
         <p:spPr>
           <a:xfrm>
-            <a:off x="812800" y="4933603"/>
+            <a:off x="812800" y="4466332"/>
             <a:ext cx="7194550" cy="452041"/>
           </a:xfrm>
           <a:prstGeom prst="rect">
@@ -13511,11 +13511,11 @@
         <p:spPr>
           <a:xfrm>
             <a:off x="8054975" y="4122837"/>
-            <a:ext cx="3321050" cy="1234232"/>
+            <a:ext cx="3321050" cy="1189881"/>
           </a:xfrm>
           <a:prstGeom prst="roundRect">
             <a:avLst>
-              <a:gd name="adj" fmla="val 7975"/>
+              <a:gd name="adj" fmla="val 8272"/>
             </a:avLst>
           </a:prstGeom>
           <a:solidFill>

</xml_diff>